<commit_message>
Improved models: habtew data, 7 h training, tuned beam search
- Attention model: 11.27 BLEU / 22.84 chrF (v1: 8.57 / 19.46); seq2seq 5.21 / 13.52
- Beam search (k=5, alpha=1.0, 3-gram blocking) tuned on validation data;
  repeated-word outputs down from 24% to 8%
- Updated checkpoints, tokenizers, ONNX web models, results, report, slides and README

Co-Authored-By: Claude Opus 5.5 <noreply@anthropic.com>
Claude-Session: https://claude.ai/code/session_01PDKn43w3hK6bUWpz4Q72jr
</commit_message>
<xml_diff>
--- a/report/presentation.pptx
+++ b/report/presentation.pptx
@@ -235,19 +235,19 @@
                 <c:formatCode>General</c:formatCode>
                 <c:ptCount val="5"/>
                 <c:pt idx="0">
-                  <c:v>669145</c:v>
+                  <c:v>906388</c:v>
                 </c:pt>
                 <c:pt idx="1">
-                  <c:v>669094</c:v>
+                  <c:v>884756</c:v>
                 </c:pt>
                 <c:pt idx="2">
-                  <c:v>663293</c:v>
+                  <c:v>878906</c:v>
                 </c:pt>
                 <c:pt idx="3">
-                  <c:v>442746</c:v>
+                  <c:v>583019</c:v>
                 </c:pt>
                 <c:pt idx="4">
-                  <c:v>435665</c:v>
+                  <c:v>525095</c:v>
                 </c:pt>
               </c:numCache>
             </c:numRef>
@@ -467,10 +467,10 @@
                 <c:formatCode>General</c:formatCode>
                 <c:ptCount val="2"/>
                 <c:pt idx="0">
-                  <c:v>2.97</c:v>
+                  <c:v>5.21</c:v>
                 </c:pt>
                 <c:pt idx="1">
-                  <c:v>12.16</c:v>
+                  <c:v>13.52</c:v>
                 </c:pt>
               </c:numCache>
             </c:numRef>
@@ -544,10 +544,10 @@
                 <c:formatCode>General</c:formatCode>
                 <c:ptCount val="2"/>
                 <c:pt idx="0">
-                  <c:v>8.57</c:v>
+                  <c:v>11.27</c:v>
                 </c:pt>
                 <c:pt idx="1">
-                  <c:v>19.46</c:v>
+                  <c:v>22.84</c:v>
                 </c:pt>
               </c:numCache>
             </c:numRef>
@@ -816,16 +816,16 @@
                 <c:formatCode>General</c:formatCode>
                 <c:ptCount val="4"/>
                 <c:pt idx="0">
-                  <c:v>7.02</c:v>
+                  <c:v>11.94</c:v>
                 </c:pt>
                 <c:pt idx="1">
-                  <c:v>3.26</c:v>
+                  <c:v>5.85</c:v>
                 </c:pt>
                 <c:pt idx="2">
-                  <c:v>2.57</c:v>
+                  <c:v>4.4</c:v>
                 </c:pt>
                 <c:pt idx="3">
-                  <c:v>1.91</c:v>
+                  <c:v>3.22</c:v>
                 </c:pt>
               </c:numCache>
             </c:numRef>
@@ -905,16 +905,16 @@
                 <c:formatCode>General</c:formatCode>
                 <c:ptCount val="4"/>
                 <c:pt idx="0">
-                  <c:v>15.52</c:v>
+                  <c:v>19.52</c:v>
                 </c:pt>
                 <c:pt idx="1">
-                  <c:v>9.67</c:v>
+                  <c:v>11.76</c:v>
                 </c:pt>
                 <c:pt idx="2">
-                  <c:v>7.28</c:v>
+                  <c:v>9.84</c:v>
                 </c:pt>
                 <c:pt idx="3">
-                  <c:v>7.04</c:v>
+                  <c:v>9.55</c:v>
                 </c:pt>
               </c:numCache>
             </c:numRef>
@@ -1815,7 +1815,7 @@
           <a:p>
             <a:r>
               <a:rPr lang="en-US" dirty="0"/>
-              <a:t>Explain why MT560 was chosen: documented license and 3x more data than the habtew set.</a:t>
+              <a:t>MT560 is the main corpus (documented license); habtew was added to cover everyday language. 88k habtew pairs remain after de-duplication.</a:t>
             </a:r>
             <a:endParaRPr lang="en-US" dirty="0"/>
           </a:p>
@@ -3611,7 +3611,7 @@
                 <a:ea typeface="Cambria" pitchFamily="34" charset="-122"/>
                 <a:cs typeface="Cambria" pitchFamily="34" charset="-120"/>
               </a:rPr>
-              <a:t>2.9×</a:t>
+              <a:t>2.2×</a:t>
             </a:r>
             <a:endParaRPr lang="en-US" sz="4400" dirty="0"/>
           </a:p>
@@ -3767,7 +3767,7 @@
                 <a:ea typeface="Cambria" pitchFamily="34" charset="-122"/>
                 <a:cs typeface="Cambria" pitchFamily="34" charset="-120"/>
               </a:rPr>
-              <a:t>93.55%</a:t>
+              <a:t>96.58%</a:t>
             </a:r>
             <a:endParaRPr lang="en-US" sz="4400" dirty="0"/>
           </a:p>
@@ -3806,7 +3806,7 @@
                 <a:ea typeface="Calibri" pitchFamily="34" charset="-122"/>
                 <a:cs typeface="Calibri" pitchFamily="34" charset="-120"/>
               </a:rPr>
-              <a:t>numbers copied correctly (baseline 38.28%)</a:t>
+              <a:t>numbers copied correctly (baseline 70.77%)</a:t>
             </a:r>
             <a:endParaRPr lang="en-US" sz="1300" dirty="0"/>
           </a:p>
@@ -3859,7 +3859,7 @@
                 <a:ea typeface="Calibri" pitchFamily="34" charset="-122"/>
                 <a:cs typeface="Calibri" pitchFamily="34" charset="-120"/>
               </a:rPr>
-              <a:t>longer or GPU training · beam search with repetition penalty · coverage / input feeding · more general-domain data · Transformer baseline</a:t>
+              <a:t>GPU training for more epochs · coverage / input feeding against repetition · more general-domain data · Transformer baseline</a:t>
             </a:r>
             <a:endParaRPr lang="en-US" sz="1800" dirty="0"/>
           </a:p>
@@ -4170,7 +4170,7 @@
                 <a:ea typeface="Calibri" pitchFamily="34" charset="-122"/>
                 <a:cs typeface="Calibri" pitchFamily="34" charset="-120"/>
               </a:rPr>
-              <a:t>OPUS MT560, cleaning, normalization, split</a:t>
+              <a:t>OPUS MT560 + habtew, cleaning, normalization, split</a:t>
             </a:r>
             <a:endParaRPr lang="en-US" sz="1500" dirty="0"/>
           </a:p>
@@ -5079,7 +5079,7 @@
                 <a:ea typeface="Cambria" pitchFamily="34" charset="-122"/>
                 <a:cs typeface="Cambria" pitchFamily="34" charset="-120"/>
               </a:rPr>
-              <a:t>Dataset: OPUS MT560 English–Amharic</a:t>
+              <a:t>Dataset: MT560 + habtew</a:t>
             </a:r>
             <a:endParaRPr lang="en-US" sz="3400" dirty="0"/>
           </a:p>
@@ -5118,7 +5118,7 @@
                 <a:ea typeface="Calibri" pitchFamily="34" charset="-122"/>
                 <a:cs typeface="Calibri" pitchFamily="34" charset="-120"/>
               </a:rPr>
-              <a:t>Hugging Face: michsethowusu/english-amharic_sentence-pairs_mt560  ·  License: CC-BY-4.0</a:t>
+              <a:t>HF: michsethowusu/english-amharic_sentence-pairs_mt560 (CC-BY-4.0)  ·  habtew/english-amharic-translation (no license stated)</a:t>
             </a:r>
             <a:endParaRPr lang="en-US" sz="1600" dirty="0"/>
           </a:p>
@@ -5157,7 +5157,7 @@
                 <a:ea typeface="Cambria" pitchFamily="34" charset="-122"/>
                 <a:cs typeface="Cambria" pitchFamily="34" charset="-120"/>
               </a:rPr>
-              <a:t>669,145</a:t>
+              <a:t>906,388</a:t>
             </a:r>
             <a:endParaRPr lang="en-US" sz="4400" dirty="0"/>
           </a:p>
@@ -5235,7 +5235,7 @@
                 <a:ea typeface="Cambria" pitchFamily="34" charset="-122"/>
                 <a:cs typeface="Cambria" pitchFamily="34" charset="-120"/>
               </a:rPr>
-              <a:t>427,665</a:t>
+              <a:t>517,095</a:t>
             </a:r>
             <a:endParaRPr lang="en-US" sz="4400" dirty="0"/>
           </a:p>
@@ -5411,7 +5411,7 @@
                 <a:ea typeface="Calibri" pitchFamily="34" charset="-122"/>
                 <a:cs typeface="Calibri" pitchFamily="34" charset="-120"/>
               </a:rPr>
-              <a:t>Religious domain: Bible, Qur'an, Watchtower texts</a:t>
+              <a:t>MT560: religious (Bible, Qur'an, Watchtower); habtew adds news and everyday sentences</a:t>
             </a:r>
             <a:endParaRPr lang="en-US" sz="1400" dirty="0"/>
           </a:p>
@@ -5432,7 +5432,7 @@
                 <a:ea typeface="Calibri" pitchFamily="34" charset="-122"/>
                 <a:cs typeface="Calibri" pitchFamily="34" charset="-120"/>
               </a:rPr>
-              <a:t>Amharic has 4× more word types than English (rich morphology)</a:t>
+              <a:t>Amharic has 3× more word types than English (rich morphology)</a:t>
             </a:r>
             <a:endParaRPr lang="en-US" sz="1400" dirty="0"/>
           </a:p>
@@ -6826,7 +6826,7 @@
                           <a:ea typeface="Calibri" pitchFamily="34" charset="-122"/>
                           <a:cs typeface="Calibri" pitchFamily="34" charset="-120"/>
                         </a:rPr>
-                        <a:t>4 (150-minute budget per model)</a:t>
+                        <a:t>6 (7-hour budget per model)</a:t>
                       </a:r>
                       <a:endParaRPr lang="en-US" sz="1400" dirty="0">
                         <a:latin typeface="Calibri" charset="0"/>
@@ -7185,7 +7185,7 @@
                 <a:ea typeface="Calibri" pitchFamily="34" charset="-122"/>
                 <a:cs typeface="Calibri" pitchFamily="34" charset="-120"/>
               </a:rPr>
-              <a:t>Both models were still improving when the time budget ended; the gap opens in epoch 1.</a:t>
+              <a:t>The gap between the models opens in epoch 1 and keeps growing; both were still slowly improving.</a:t>
             </a:r>
             <a:endParaRPr lang="en-US" sz="1400" dirty="0"/>
           </a:p>
@@ -7288,7 +7288,7 @@
                 <a:ea typeface="Calibri" pitchFamily="34" charset="-122"/>
                 <a:cs typeface="Calibri" pitchFamily="34" charset="-120"/>
               </a:rPr>
-              <a:t>Test set, 5,000 sentences, greedy decoding</a:t>
+              <a:t>Test set, 5,000 sentences, beam search (k=5)</a:t>
             </a:r>
             <a:endParaRPr lang="en-US" sz="1600" dirty="0"/>
           </a:p>
@@ -7327,7 +7327,7 @@
                 <a:ea typeface="Cambria" pitchFamily="34" charset="-122"/>
                 <a:cs typeface="Cambria" pitchFamily="34" charset="-120"/>
               </a:rPr>
-              <a:t>8.57</a:t>
+              <a:t>11.27</a:t>
             </a:r>
             <a:endParaRPr lang="en-US" sz="4400" dirty="0"/>
           </a:p>
@@ -7366,7 +7366,7 @@
                 <a:ea typeface="Calibri" pitchFamily="34" charset="-122"/>
                 <a:cs typeface="Calibri" pitchFamily="34" charset="-120"/>
               </a:rPr>
-              <a:t>BLEU with attention (baseline 2.97)</a:t>
+              <a:t>BLEU with attention (baseline 5.21)</a:t>
             </a:r>
             <a:endParaRPr lang="en-US" sz="1300" dirty="0"/>
           </a:p>
@@ -7405,7 +7405,7 @@
                 <a:ea typeface="Cambria" pitchFamily="34" charset="-122"/>
                 <a:cs typeface="Cambria" pitchFamily="34" charset="-120"/>
               </a:rPr>
-              <a:t>19.46</a:t>
+              <a:t>22.84</a:t>
             </a:r>
             <a:endParaRPr lang="en-US" sz="4400" dirty="0"/>
           </a:p>
@@ -7444,7 +7444,7 @@
                 <a:ea typeface="Calibri" pitchFamily="34" charset="-122"/>
                 <a:cs typeface="Calibri" pitchFamily="34" charset="-120"/>
               </a:rPr>
-              <a:t>chrF with attention (baseline 12.16)</a:t>
+              <a:t>chrF with attention (baseline 13.52)</a:t>
             </a:r>
             <a:endParaRPr lang="en-US" sz="1300" dirty="0"/>
           </a:p>
@@ -7483,7 +7483,7 @@
                 <a:ea typeface="Cambria" pitchFamily="34" charset="-122"/>
                 <a:cs typeface="Cambria" pitchFamily="34" charset="-120"/>
               </a:rPr>
-              <a:t>3.55</a:t>
+              <a:t>3.20</a:t>
             </a:r>
             <a:endParaRPr lang="en-US" sz="4400" dirty="0"/>
           </a:p>
@@ -7522,7 +7522,7 @@
                 <a:ea typeface="Calibri" pitchFamily="34" charset="-122"/>
                 <a:cs typeface="Calibri" pitchFamily="34" charset="-120"/>
               </a:rPr>
-              <a:t>test loss with attention (baseline 3.97)</a:t>
+              <a:t>test loss with attention (baseline 3.70)</a:t>
             </a:r>
             <a:endParaRPr lang="en-US" sz="1300" dirty="0"/>
           </a:p>
@@ -7560,16 +7560,16 @@
         </p:nvGraphicFramePr>
         <p:xfrm>
           <a:off x="7680960" y="1828800"/>
-          <a:ext cx="4023360" cy="914400"/>
+          <a:ext cx="4206240" cy="914400"/>
         </p:xfrm>
         <a:graphic>
           <a:graphicData uri="http://schemas.openxmlformats.org/drawingml/2006/table">
             <a:tbl>
               <a:tblPr/>
               <a:tblGrid>
-                <a:gridCol w="1737360"/>
-                <a:gridCol w="1143000"/>
-                <a:gridCol w="1143000"/>
+                <a:gridCol w="1554480"/>
+                <a:gridCol w="1325880"/>
+                <a:gridCol w="1325880"/>
               </a:tblGrid>
               <a:tr h="457200">
                 <a:tc>
@@ -8058,7 +8058,7 @@
                           <a:ea typeface="Calibri" pitchFamily="34" charset="-122"/>
                           <a:cs typeface="Calibri" pitchFamily="34" charset="-120"/>
                         </a:rPr>
-                        <a:t>150.1 min</a:t>
+                        <a:t>420.2 min</a:t>
                       </a:r>
                       <a:endParaRPr lang="en-US" sz="1300" dirty="0">
                         <a:latin typeface="Calibri" charset="0"/>
@@ -8126,7 +8126,7 @@
                           <a:ea typeface="Calibri" pitchFamily="34" charset="-122"/>
                           <a:cs typeface="Calibri" pitchFamily="34" charset="-120"/>
                         </a:rPr>
-                        <a:t>150.2 min</a:t>
+                        <a:t>420.2 min</a:t>
                       </a:r>
                       <a:endParaRPr lang="en-US" sz="1300" dirty="0">
                         <a:latin typeface="Calibri" charset="0"/>
@@ -8264,7 +8264,7 @@
                           <a:ea typeface="Calibri" pitchFamily="34" charset="-122"/>
                           <a:cs typeface="Calibri" pitchFamily="34" charset="-120"/>
                         </a:rPr>
-                        <a:t>53.21</a:t>
+                        <a:t>40.48</a:t>
                       </a:r>
                       <a:endParaRPr lang="en-US" sz="1300" dirty="0">
                         <a:latin typeface="Calibri" charset="0"/>
@@ -8332,7 +8332,213 @@
                           <a:ea typeface="Calibri" pitchFamily="34" charset="-122"/>
                           <a:cs typeface="Calibri" pitchFamily="34" charset="-120"/>
                         </a:rPr>
-                        <a:t>34.73</a:t>
+                        <a:t>24.57</a:t>
+                      </a:r>
+                      <a:endParaRPr lang="en-US" sz="1300" dirty="0">
+                        <a:latin typeface="Calibri" charset="0"/>
+                        <a:ea typeface="Calibri" charset="0"/>
+                        <a:cs typeface="Calibri" charset="0"/>
+                      </a:endParaRPr>
+                    </a:p>
+                  </a:txBody>
+                  <a:tcPr marL="91440" marR="91440" marT="45720" marB="45720">
+                    <a:lnL w="6350" cap="flat" cmpd="sng" algn="ctr">
+                      <a:solidFill>
+                        <a:srgbClr val="D9DEE3"/>
+                      </a:solidFill>
+                      <a:prstDash val="solid"/>
+                      <a:round/>
+                      <a:headEnd type="none" w="med" len="med"/>
+                      <a:tailEnd type="none" w="med" len="med"/>
+                    </a:lnL>
+                    <a:lnR w="6350" cap="flat" cmpd="sng" algn="ctr">
+                      <a:solidFill>
+                        <a:srgbClr val="D9DEE3"/>
+                      </a:solidFill>
+                      <a:prstDash val="solid"/>
+                      <a:round/>
+                      <a:headEnd type="none" w="med" len="med"/>
+                      <a:tailEnd type="none" w="med" len="med"/>
+                    </a:lnR>
+                    <a:lnT w="6350" cap="flat" cmpd="sng" algn="ctr">
+                      <a:solidFill>
+                        <a:srgbClr val="D9DEE3"/>
+                      </a:solidFill>
+                      <a:prstDash val="solid"/>
+                      <a:round/>
+                      <a:headEnd type="none" w="med" len="med"/>
+                      <a:tailEnd type="none" w="med" len="med"/>
+                    </a:lnT>
+                    <a:lnB w="6350" cap="flat" cmpd="sng" algn="ctr">
+                      <a:solidFill>
+                        <a:srgbClr val="D9DEE3"/>
+                      </a:solidFill>
+                      <a:prstDash val="solid"/>
+                      <a:round/>
+                      <a:headEnd type="none" w="med" len="med"/>
+                      <a:tailEnd type="none" w="med" len="med"/>
+                    </a:lnB>
+                    <a:solidFill>
+                      <a:srgbClr val="FFFFFF"/>
+                    </a:solidFill>
+                  </a:tcPr>
+                </a:tc>
+              </a:tr>
+              <a:tr h="457200">
+                <a:tc>
+                  <a:txBody>
+                    <a:bodyPr/>
+                    <a:lstStyle/>
+                    <a:p>
+                      <a:pPr algn="l" indent="0" marL="0">
+                        <a:buNone/>
+                      </a:pPr>
+                      <a:r>
+                        <a:rPr lang="en-US" sz="1300" b="1" dirty="0">
+                          <a:solidFill>
+                            <a:srgbClr val="1B1F24"/>
+                          </a:solidFill>
+                          <a:latin typeface="Calibri" pitchFamily="34" charset="0"/>
+                          <a:ea typeface="Calibri" pitchFamily="34" charset="-122"/>
+                          <a:cs typeface="Calibri" pitchFamily="34" charset="-120"/>
+                        </a:rPr>
+                        <a:t>Beam / greedy BLEU</a:t>
+                      </a:r>
+                      <a:endParaRPr lang="en-US" sz="1300" dirty="0">
+                        <a:latin typeface="Calibri" charset="0"/>
+                        <a:ea typeface="Calibri" charset="0"/>
+                        <a:cs typeface="Calibri" charset="0"/>
+                      </a:endParaRPr>
+                    </a:p>
+                  </a:txBody>
+                  <a:tcPr marL="91440" marR="91440" marT="45720" marB="45720">
+                    <a:lnL w="6350" cap="flat" cmpd="sng" algn="ctr">
+                      <a:solidFill>
+                        <a:srgbClr val="D9DEE3"/>
+                      </a:solidFill>
+                      <a:prstDash val="solid"/>
+                      <a:round/>
+                      <a:headEnd type="none" w="med" len="med"/>
+                      <a:tailEnd type="none" w="med" len="med"/>
+                    </a:lnL>
+                    <a:lnR w="6350" cap="flat" cmpd="sng" algn="ctr">
+                      <a:solidFill>
+                        <a:srgbClr val="D9DEE3"/>
+                      </a:solidFill>
+                      <a:prstDash val="solid"/>
+                      <a:round/>
+                      <a:headEnd type="none" w="med" len="med"/>
+                      <a:tailEnd type="none" w="med" len="med"/>
+                    </a:lnR>
+                    <a:lnT w="6350" cap="flat" cmpd="sng" algn="ctr">
+                      <a:solidFill>
+                        <a:srgbClr val="D9DEE3"/>
+                      </a:solidFill>
+                      <a:prstDash val="solid"/>
+                      <a:round/>
+                      <a:headEnd type="none" w="med" len="med"/>
+                      <a:tailEnd type="none" w="med" len="med"/>
+                    </a:lnT>
+                    <a:lnB w="6350" cap="flat" cmpd="sng" algn="ctr">
+                      <a:solidFill>
+                        <a:srgbClr val="D9DEE3"/>
+                      </a:solidFill>
+                      <a:prstDash val="solid"/>
+                      <a:round/>
+                      <a:headEnd type="none" w="med" len="med"/>
+                      <a:tailEnd type="none" w="med" len="med"/>
+                    </a:lnB>
+                    <a:solidFill>
+                      <a:srgbClr val="FFFFFF"/>
+                    </a:solidFill>
+                  </a:tcPr>
+                </a:tc>
+                <a:tc>
+                  <a:txBody>
+                    <a:bodyPr/>
+                    <a:lstStyle/>
+                    <a:p>
+                      <a:pPr algn="r" indent="0" marL="0">
+                        <a:buNone/>
+                      </a:pPr>
+                      <a:r>
+                        <a:rPr lang="en-US" sz="1300" dirty="0">
+                          <a:solidFill>
+                            <a:srgbClr val="1B1F24"/>
+                          </a:solidFill>
+                          <a:latin typeface="Calibri" pitchFamily="34" charset="0"/>
+                          <a:ea typeface="Calibri" pitchFamily="34" charset="-122"/>
+                          <a:cs typeface="Calibri" pitchFamily="34" charset="-120"/>
+                        </a:rPr>
+                        <a:t>5.21 / 4.77</a:t>
+                      </a:r>
+                      <a:endParaRPr lang="en-US" sz="1300" dirty="0">
+                        <a:latin typeface="Calibri" charset="0"/>
+                        <a:ea typeface="Calibri" charset="0"/>
+                        <a:cs typeface="Calibri" charset="0"/>
+                      </a:endParaRPr>
+                    </a:p>
+                  </a:txBody>
+                  <a:tcPr marL="91440" marR="91440" marT="45720" marB="45720">
+                    <a:lnL w="6350" cap="flat" cmpd="sng" algn="ctr">
+                      <a:solidFill>
+                        <a:srgbClr val="D9DEE3"/>
+                      </a:solidFill>
+                      <a:prstDash val="solid"/>
+                      <a:round/>
+                      <a:headEnd type="none" w="med" len="med"/>
+                      <a:tailEnd type="none" w="med" len="med"/>
+                    </a:lnL>
+                    <a:lnR w="6350" cap="flat" cmpd="sng" algn="ctr">
+                      <a:solidFill>
+                        <a:srgbClr val="D9DEE3"/>
+                      </a:solidFill>
+                      <a:prstDash val="solid"/>
+                      <a:round/>
+                      <a:headEnd type="none" w="med" len="med"/>
+                      <a:tailEnd type="none" w="med" len="med"/>
+                    </a:lnR>
+                    <a:lnT w="6350" cap="flat" cmpd="sng" algn="ctr">
+                      <a:solidFill>
+                        <a:srgbClr val="D9DEE3"/>
+                      </a:solidFill>
+                      <a:prstDash val="solid"/>
+                      <a:round/>
+                      <a:headEnd type="none" w="med" len="med"/>
+                      <a:tailEnd type="none" w="med" len="med"/>
+                    </a:lnT>
+                    <a:lnB w="6350" cap="flat" cmpd="sng" algn="ctr">
+                      <a:solidFill>
+                        <a:srgbClr val="D9DEE3"/>
+                      </a:solidFill>
+                      <a:prstDash val="solid"/>
+                      <a:round/>
+                      <a:headEnd type="none" w="med" len="med"/>
+                      <a:tailEnd type="none" w="med" len="med"/>
+                    </a:lnB>
+                    <a:solidFill>
+                      <a:srgbClr val="FFFFFF"/>
+                    </a:solidFill>
+                  </a:tcPr>
+                </a:tc>
+                <a:tc>
+                  <a:txBody>
+                    <a:bodyPr/>
+                    <a:lstStyle/>
+                    <a:p>
+                      <a:pPr algn="r" indent="0" marL="0">
+                        <a:buNone/>
+                      </a:pPr>
+                      <a:r>
+                        <a:rPr lang="en-US" sz="1300" dirty="0">
+                          <a:solidFill>
+                            <a:srgbClr val="1B1F24"/>
+                          </a:solidFill>
+                          <a:latin typeface="Calibri" pitchFamily="34" charset="0"/>
+                          <a:ea typeface="Calibri" pitchFamily="34" charset="-122"/>
+                          <a:cs typeface="Calibri" pitchFamily="34" charset="-120"/>
+                        </a:rPr>
+                        <a:t>11.27 / 10.23</a:t>
                       </a:r>
                       <a:endParaRPr lang="en-US" sz="1300" dirty="0">
                         <a:latin typeface="Calibri" charset="0"/>
@@ -8470,7 +8676,7 @@
                           <a:ea typeface="Calibri" pitchFamily="34" charset="-122"/>
                           <a:cs typeface="Calibri" pitchFamily="34" charset="-120"/>
                         </a:rPr>
-                        <a:t>19.5 ms</a:t>
+                        <a:t>63.7 ms</a:t>
                       </a:r>
                       <a:endParaRPr lang="en-US" sz="1300" dirty="0">
                         <a:latin typeface="Calibri" charset="0"/>
@@ -8538,7 +8744,7 @@
                           <a:ea typeface="Calibri" pitchFamily="34" charset="-122"/>
                           <a:cs typeface="Calibri" pitchFamily="34" charset="-120"/>
                         </a:rPr>
-                        <a:t>22.1 ms</a:t>
+                        <a:t>81.3 ms</a:t>
                       </a:r>
                       <a:endParaRPr lang="en-US" sz="1300" dirty="0">
                         <a:latin typeface="Calibri" charset="0"/>
@@ -8608,7 +8814,7 @@
                           <a:ea typeface="Calibri" pitchFamily="34" charset="-122"/>
                           <a:cs typeface="Calibri" pitchFamily="34" charset="-120"/>
                         </a:rPr>
-                        <a:t>Test set (batched)</a:t>
+                        <a:t>Test set, beam</a:t>
                       </a:r>
                       <a:endParaRPr lang="en-US" sz="1300" dirty="0">
                         <a:latin typeface="Calibri" charset="0"/>
@@ -8676,7 +8882,7 @@
                           <a:ea typeface="Calibri" pitchFamily="34" charset="-122"/>
                           <a:cs typeface="Calibri" pitchFamily="34" charset="-120"/>
                         </a:rPr>
-                        <a:t>9.7 s</a:t>
+                        <a:t>406.2 s</a:t>
                       </a:r>
                       <a:endParaRPr lang="en-US" sz="1300" dirty="0">
                         <a:latin typeface="Calibri" charset="0"/>
@@ -8744,7 +8950,7 @@
                           <a:ea typeface="Calibri" pitchFamily="34" charset="-122"/>
                           <a:cs typeface="Calibri" pitchFamily="34" charset="-120"/>
                         </a:rPr>
-                        <a:t>16.8 s</a:t>
+                        <a:t>394.2 s</a:t>
                       </a:r>
                       <a:endParaRPr lang="en-US" sz="1300" dirty="0">
                         <a:latin typeface="Calibri" charset="0"/>
@@ -8808,8 +9014,8 @@
         </p:nvSpPr>
         <p:spPr>
           <a:xfrm>
-            <a:off x="7680960" y="4937760"/>
-            <a:ext cx="4023360" cy="822960"/>
+            <a:off x="7680960" y="5440680"/>
+            <a:ext cx="4206240" cy="822960"/>
           </a:xfrm>
           <a:prstGeom prst="rect">
             <a:avLst/>
@@ -8833,7 +9039,7 @@
                 <a:ea typeface="Calibri" pitchFamily="34" charset="-122"/>
                 <a:cs typeface="Calibri" pitchFamily="34" charset="-120"/>
               </a:rPr>
-              <a:t>+5.6 BLEU for +2.5% parameters; about 3 ms slower per sentence.</a:t>
+              <a:t>+6.1 BLEU for +2.5% parameters. Beam search adds +1.0 BLEU over greedy decoding.</a:t>
             </a:r>
             <a:endParaRPr lang="en-US" sz="1400" dirty="0"/>
           </a:p>
@@ -8936,7 +9142,7 @@
                 <a:ea typeface="Calibri" pitchFamily="34" charset="-122"/>
                 <a:cs typeface="Calibri" pitchFamily="34" charset="-120"/>
               </a:rPr>
-              <a:t>Source → Reference → Seq2Seq → Attention-LSTM</a:t>
+              <a:t>Source → Seq2Seq → Attention-LSTM (beam search); full table with references in results/examples.md</a:t>
             </a:r>
             <a:endParaRPr lang="en-US" sz="1600" dirty="0"/>
           </a:p>
@@ -8965,10 +9171,9 @@
             <a:tbl>
               <a:tblPr/>
               <a:tblGrid>
-                <a:gridCol w="2834640"/>
-                <a:gridCol w="2743200"/>
-                <a:gridCol w="2743200"/>
-                <a:gridCol w="2743200"/>
+                <a:gridCol w="3749040"/>
+                <a:gridCol w="3657600"/>
+                <a:gridCol w="3657600"/>
               </a:tblGrid>
               <a:tr h="731520">
                 <a:tc>
@@ -8989,50 +9194,6 @@
                           <a:cs typeface="Calibri" pitchFamily="34" charset="-120"/>
                         </a:rPr>
                         <a:t>Source (EN)</a:t>
-                      </a:r>
-                      <a:endParaRPr lang="en-US" sz="1200" dirty="0">
-                        <a:latin typeface="Calibri" charset="0"/>
-                        <a:ea typeface="Calibri" charset="0"/>
-                        <a:cs typeface="Calibri" charset="0"/>
-                      </a:endParaRPr>
-                    </a:p>
-                  </a:txBody>
-                  <a:tcPr marL="91440" marR="91440" marT="45720" marB="45720" anchor="ctr">
-                    <a:lnL w="0" cap="flat" cmpd="sng" algn="ctr">
-                      <a:noFill/>
-                    </a:lnL>
-                    <a:lnR w="0" cap="flat" cmpd="sng" algn="ctr">
-                      <a:noFill/>
-                    </a:lnR>
-                    <a:lnT w="0" cap="flat" cmpd="sng" algn="ctr">
-                      <a:noFill/>
-                    </a:lnT>
-                    <a:lnB w="0" cap="flat" cmpd="sng" algn="ctr">
-                      <a:noFill/>
-                    </a:lnB>
-                    <a:solidFill>
-                      <a:srgbClr val="1F5C4A"/>
-                    </a:solidFill>
-                  </a:tcPr>
-                </a:tc>
-                <a:tc>
-                  <a:txBody>
-                    <a:bodyPr/>
-                    <a:lstStyle/>
-                    <a:p>
-                      <a:pPr indent="0" marL="0">
-                        <a:buNone/>
-                      </a:pPr>
-                      <a:r>
-                        <a:rPr lang="en-US" sz="1200" b="1" dirty="0">
-                          <a:solidFill>
-                            <a:srgbClr val="FFFFFF"/>
-                          </a:solidFill>
-                          <a:latin typeface="Calibri" pitchFamily="34" charset="0"/>
-                          <a:ea typeface="Calibri" pitchFamily="34" charset="-122"/>
-                          <a:cs typeface="Calibri" pitchFamily="34" charset="-120"/>
-                        </a:rPr>
-                        <a:t>Reference (AM)</a:t>
                       </a:r>
                       <a:endParaRPr lang="en-US" sz="1200" dirty="0">
                         <a:latin typeface="Calibri" charset="0"/>
@@ -9166,7 +9327,7 @@
                           <a:ea typeface="Calibri" pitchFamily="34" charset="-122"/>
                           <a:cs typeface="Calibri" pitchFamily="34" charset="-120"/>
                         </a:rPr>
-                        <a:t>six years later, my father died.</a:t>
+                        <a:t>I am going to the university.</a:t>
                       </a:r>
                       <a:endParaRPr lang="en-US" sz="1300" dirty="0">
                         <a:latin typeface="Calibri" charset="0"/>
@@ -9210,7 +9371,7 @@
                           <a:ea typeface="Nyala" pitchFamily="34" charset="-122"/>
                           <a:cs typeface="Nyala" pitchFamily="34" charset="-120"/>
                         </a:rPr>
-                        <a:t>ከስድስት አመት በኋላ አባቴ ሞተ።</a:t>
+                        <a:t>ብዬ አሰብኩ።</a:t>
                       </a:r>
                       <a:endParaRPr lang="en-US" sz="1500" dirty="0">
                         <a:latin typeface="Nyala" charset="0"/>
@@ -9254,51 +9415,7 @@
                           <a:ea typeface="Nyala" pitchFamily="34" charset="-122"/>
                           <a:cs typeface="Nyala" pitchFamily="34" charset="-120"/>
                         </a:rPr>
-                        <a:t>አባቴ አባቴን ወለድኩ።</a:t>
-                      </a:r>
-                      <a:endParaRPr lang="en-US" sz="1500" dirty="0">
-                        <a:latin typeface="Nyala" charset="0"/>
-                        <a:ea typeface="Nyala" charset="0"/>
-                        <a:cs typeface="Nyala" charset="0"/>
-                      </a:endParaRPr>
-                    </a:p>
-                  </a:txBody>
-                  <a:tcPr marL="91440" marR="91440" marT="45720" marB="45720" anchor="ctr">
-                    <a:lnL w="0" cap="flat" cmpd="sng" algn="ctr">
-                      <a:noFill/>
-                    </a:lnL>
-                    <a:lnR w="0" cap="flat" cmpd="sng" algn="ctr">
-                      <a:noFill/>
-                    </a:lnR>
-                    <a:lnT w="0" cap="flat" cmpd="sng" algn="ctr">
-                      <a:noFill/>
-                    </a:lnT>
-                    <a:lnB w="0" cap="flat" cmpd="sng" algn="ctr">
-                      <a:noFill/>
-                    </a:lnB>
-                    <a:solidFill>
-                      <a:srgbClr val="F4F7F6"/>
-                    </a:solidFill>
-                  </a:tcPr>
-                </a:tc>
-                <a:tc>
-                  <a:txBody>
-                    <a:bodyPr/>
-                    <a:lstStyle/>
-                    <a:p>
-                      <a:pPr indent="0" marL="0">
-                        <a:buNone/>
-                      </a:pPr>
-                      <a:r>
-                        <a:rPr lang="en-US" sz="1500" dirty="0">
-                          <a:solidFill>
-                            <a:srgbClr val="1B1F24"/>
-                          </a:solidFill>
-                          <a:latin typeface="Nyala" pitchFamily="34" charset="0"/>
-                          <a:ea typeface="Nyala" pitchFamily="34" charset="-122"/>
-                          <a:cs typeface="Nyala" pitchFamily="34" charset="-120"/>
-                        </a:rPr>
-                        <a:t>ከሁለት አመት በኋላ አባቴ ሞተ።</a:t>
+                        <a:t>ወደ ዩኒቨርሲቲው ሄድኩ።</a:t>
                       </a:r>
                       <a:endParaRPr lang="en-US" sz="1500" dirty="0">
                         <a:latin typeface="Nyala" charset="0"/>
@@ -9344,7 +9461,7 @@
                           <a:ea typeface="Calibri" pitchFamily="34" charset="-122"/>
                           <a:cs typeface="Calibri" pitchFamily="34" charset="-120"/>
                         </a:rPr>
-                        <a:t>what are some factors that promote this unity?</a:t>
+                        <a:t>Jesus taught his disciples to love one another.</a:t>
                       </a:r>
                       <a:endParaRPr lang="en-US" sz="1300" dirty="0">
                         <a:latin typeface="Calibri" charset="0"/>
@@ -9388,7 +9505,7 @@
                           <a:ea typeface="Nyala" pitchFamily="34" charset="-122"/>
                           <a:cs typeface="Nyala" pitchFamily="34" charset="-120"/>
                         </a:rPr>
-                        <a:t>ለዚህ አንድነት አስተዋጽኦ ያደረጉት አንዳንድ ነገሮች ምንድን ናቸው?</a:t>
+                        <a:t>ኢየሱስ ደቀ መዛሙርቱ እርስ በርስ እርስ በርስ ተነጋገሩ።</a:t>
                       </a:r>
                       <a:endParaRPr lang="en-US" sz="1500" dirty="0">
                         <a:latin typeface="Nyala" charset="0"/>
@@ -9432,7 +9549,7 @@
                           <a:ea typeface="Nyala" pitchFamily="34" charset="-122"/>
                           <a:cs typeface="Nyala" pitchFamily="34" charset="-120"/>
                         </a:rPr>
-                        <a:t>ይህ ሲባል ምን ማለት ነው?</a:t>
+                        <a:t>ኢየሱስ ደቀ መዛሙርቱ እርስ በርስ እንዲወደዱ አስተምሯቸዋል።</a:t>
                       </a:r>
                       <a:endParaRPr lang="en-US" sz="1500" dirty="0">
                         <a:latin typeface="Nyala" charset="0"/>
@@ -9456,228 +9573,6 @@
                     </a:lnB>
                     <a:solidFill>
                       <a:srgbClr val="FFFFFF"/>
-                    </a:solidFill>
-                  </a:tcPr>
-                </a:tc>
-                <a:tc>
-                  <a:txBody>
-                    <a:bodyPr/>
-                    <a:lstStyle/>
-                    <a:p>
-                      <a:pPr indent="0" marL="0">
-                        <a:buNone/>
-                      </a:pPr>
-                      <a:r>
-                        <a:rPr lang="en-US" sz="1500" dirty="0">
-                          <a:solidFill>
-                            <a:srgbClr val="1B1F24"/>
-                          </a:solidFill>
-                          <a:latin typeface="Nyala" pitchFamily="34" charset="0"/>
-                          <a:ea typeface="Nyala" pitchFamily="34" charset="-122"/>
-                          <a:cs typeface="Nyala" pitchFamily="34" charset="-120"/>
-                        </a:rPr>
-                        <a:t>ይህን አንድነት ለማጠናከር አንዳንድ ምክንያቶች ምንድን ናቸው?</a:t>
-                      </a:r>
-                      <a:endParaRPr lang="en-US" sz="1500" dirty="0">
-                        <a:latin typeface="Nyala" charset="0"/>
-                        <a:ea typeface="Nyala" charset="0"/>
-                        <a:cs typeface="Nyala" charset="0"/>
-                      </a:endParaRPr>
-                    </a:p>
-                  </a:txBody>
-                  <a:tcPr marL="91440" marR="91440" marT="45720" marB="45720" anchor="ctr">
-                    <a:lnL w="0" cap="flat" cmpd="sng" algn="ctr">
-                      <a:noFill/>
-                    </a:lnL>
-                    <a:lnR w="0" cap="flat" cmpd="sng" algn="ctr">
-                      <a:noFill/>
-                    </a:lnR>
-                    <a:lnT w="0" cap="flat" cmpd="sng" algn="ctr">
-                      <a:noFill/>
-                    </a:lnT>
-                    <a:lnB w="0" cap="flat" cmpd="sng" algn="ctr">
-                      <a:noFill/>
-                    </a:lnB>
-                    <a:solidFill>
-                      <a:srgbClr val="FFFFFF"/>
-                    </a:solidFill>
-                  </a:tcPr>
-                </a:tc>
-              </a:tr>
-              <a:tr h="731520">
-                <a:tc>
-                  <a:txBody>
-                    <a:bodyPr/>
-                    <a:lstStyle/>
-                    <a:p>
-                      <a:pPr indent="0" marL="0">
-                        <a:buNone/>
-                      </a:pPr>
-                      <a:r>
-                        <a:rPr lang="en-US" sz="1300" dirty="0">
-                          <a:solidFill>
-                            <a:srgbClr val="1B1F24"/>
-                          </a:solidFill>
-                          <a:latin typeface="Calibri" pitchFamily="34" charset="0"/>
-                          <a:ea typeface="Calibri" pitchFamily="34" charset="-122"/>
-                          <a:cs typeface="Calibri" pitchFamily="34" charset="-120"/>
-                        </a:rPr>
-                        <a:t>songs: 100, 87</a:t>
-                      </a:r>
-                      <a:endParaRPr lang="en-US" sz="1300" dirty="0">
-                        <a:latin typeface="Calibri" charset="0"/>
-                        <a:ea typeface="Calibri" charset="0"/>
-                        <a:cs typeface="Calibri" charset="0"/>
-                      </a:endParaRPr>
-                    </a:p>
-                  </a:txBody>
-                  <a:tcPr marL="91440" marR="91440" marT="45720" marB="45720" anchor="ctr">
-                    <a:lnL w="0" cap="flat" cmpd="sng" algn="ctr">
-                      <a:noFill/>
-                    </a:lnL>
-                    <a:lnR w="0" cap="flat" cmpd="sng" algn="ctr">
-                      <a:noFill/>
-                    </a:lnR>
-                    <a:lnT w="0" cap="flat" cmpd="sng" algn="ctr">
-                      <a:noFill/>
-                    </a:lnT>
-                    <a:lnB w="0" cap="flat" cmpd="sng" algn="ctr">
-                      <a:noFill/>
-                    </a:lnB>
-                    <a:solidFill>
-                      <a:srgbClr val="F4F7F6"/>
-                    </a:solidFill>
-                  </a:tcPr>
-                </a:tc>
-                <a:tc>
-                  <a:txBody>
-                    <a:bodyPr/>
-                    <a:lstStyle/>
-                    <a:p>
-                      <a:pPr indent="0" marL="0">
-                        <a:buNone/>
-                      </a:pPr>
-                      <a:r>
-                        <a:rPr lang="en-US" sz="1500" dirty="0">
-                          <a:solidFill>
-                            <a:srgbClr val="1B1F24"/>
-                          </a:solidFill>
-                          <a:latin typeface="Nyala" pitchFamily="34" charset="0"/>
-                          <a:ea typeface="Nyala" pitchFamily="34" charset="-122"/>
-                          <a:cs typeface="Nyala" pitchFamily="34" charset="-120"/>
-                        </a:rPr>
-                        <a:t>መዝሙሮች፦ 100, 87</a:t>
-                      </a:r>
-                      <a:endParaRPr lang="en-US" sz="1500" dirty="0">
-                        <a:latin typeface="Nyala" charset="0"/>
-                        <a:ea typeface="Nyala" charset="0"/>
-                        <a:cs typeface="Nyala" charset="0"/>
-                      </a:endParaRPr>
-                    </a:p>
-                  </a:txBody>
-                  <a:tcPr marL="91440" marR="91440" marT="45720" marB="45720" anchor="ctr">
-                    <a:lnL w="0" cap="flat" cmpd="sng" algn="ctr">
-                      <a:noFill/>
-                    </a:lnL>
-                    <a:lnR w="0" cap="flat" cmpd="sng" algn="ctr">
-                      <a:noFill/>
-                    </a:lnR>
-                    <a:lnT w="0" cap="flat" cmpd="sng" algn="ctr">
-                      <a:noFill/>
-                    </a:lnT>
-                    <a:lnB w="0" cap="flat" cmpd="sng" algn="ctr">
-                      <a:noFill/>
-                    </a:lnB>
-                    <a:solidFill>
-                      <a:srgbClr val="F4F7F6"/>
-                    </a:solidFill>
-                  </a:tcPr>
-                </a:tc>
-                <a:tc>
-                  <a:txBody>
-                    <a:bodyPr/>
-                    <a:lstStyle/>
-                    <a:p>
-                      <a:pPr indent="0" marL="0">
-                        <a:buNone/>
-                      </a:pPr>
-                      <a:r>
-                        <a:rPr lang="en-US" sz="1500" dirty="0">
-                          <a:solidFill>
-                            <a:srgbClr val="1B1F24"/>
-                          </a:solidFill>
-                          <a:latin typeface="Nyala" pitchFamily="34" charset="0"/>
-                          <a:ea typeface="Nyala" pitchFamily="34" charset="-122"/>
-                          <a:cs typeface="Nyala" pitchFamily="34" charset="-120"/>
-                        </a:rPr>
-                        <a:t>መዝሙሮች፦ 10, 70</a:t>
-                      </a:r>
-                      <a:endParaRPr lang="en-US" sz="1500" dirty="0">
-                        <a:latin typeface="Nyala" charset="0"/>
-                        <a:ea typeface="Nyala" charset="0"/>
-                        <a:cs typeface="Nyala" charset="0"/>
-                      </a:endParaRPr>
-                    </a:p>
-                  </a:txBody>
-                  <a:tcPr marL="91440" marR="91440" marT="45720" marB="45720" anchor="ctr">
-                    <a:lnL w="0" cap="flat" cmpd="sng" algn="ctr">
-                      <a:noFill/>
-                    </a:lnL>
-                    <a:lnR w="0" cap="flat" cmpd="sng" algn="ctr">
-                      <a:noFill/>
-                    </a:lnR>
-                    <a:lnT w="0" cap="flat" cmpd="sng" algn="ctr">
-                      <a:noFill/>
-                    </a:lnT>
-                    <a:lnB w="0" cap="flat" cmpd="sng" algn="ctr">
-                      <a:noFill/>
-                    </a:lnB>
-                    <a:solidFill>
-                      <a:srgbClr val="F4F7F6"/>
-                    </a:solidFill>
-                  </a:tcPr>
-                </a:tc>
-                <a:tc>
-                  <a:txBody>
-                    <a:bodyPr/>
-                    <a:lstStyle/>
-                    <a:p>
-                      <a:pPr indent="0" marL="0">
-                        <a:buNone/>
-                      </a:pPr>
-                      <a:r>
-                        <a:rPr lang="en-US" sz="1500" dirty="0">
-                          <a:solidFill>
-                            <a:srgbClr val="1B1F24"/>
-                          </a:solidFill>
-                          <a:latin typeface="Nyala" pitchFamily="34" charset="0"/>
-                          <a:ea typeface="Nyala" pitchFamily="34" charset="-122"/>
-                          <a:cs typeface="Nyala" pitchFamily="34" charset="-120"/>
-                        </a:rPr>
-                        <a:t>መዝሙሮች፦ 100, 87</a:t>
-                      </a:r>
-                      <a:endParaRPr lang="en-US" sz="1500" dirty="0">
-                        <a:latin typeface="Nyala" charset="0"/>
-                        <a:ea typeface="Nyala" charset="0"/>
-                        <a:cs typeface="Nyala" charset="0"/>
-                      </a:endParaRPr>
-                    </a:p>
-                  </a:txBody>
-                  <a:tcPr marL="91440" marR="91440" marT="45720" marB="45720" anchor="ctr">
-                    <a:lnL w="0" cap="flat" cmpd="sng" algn="ctr">
-                      <a:noFill/>
-                    </a:lnL>
-                    <a:lnR w="0" cap="flat" cmpd="sng" algn="ctr">
-                      <a:noFill/>
-                    </a:lnR>
-                    <a:lnT w="0" cap="flat" cmpd="sng" algn="ctr">
-                      <a:noFill/>
-                    </a:lnT>
-                    <a:lnB w="0" cap="flat" cmpd="sng" algn="ctr">
-                      <a:noFill/>
-                    </a:lnB>
-                    <a:solidFill>
-                      <a:srgbClr val="F4F7F6"/>
                     </a:solidFill>
                   </a:tcPr>
                 </a:tc>
@@ -9723,95 +9618,7 @@
                       <a:noFill/>
                     </a:lnB>
                     <a:solidFill>
-                      <a:srgbClr val="FFFFFF"/>
-                    </a:solidFill>
-                  </a:tcPr>
-                </a:tc>
-                <a:tc>
-                  <a:txBody>
-                    <a:bodyPr/>
-                    <a:lstStyle/>
-                    <a:p>
-                      <a:pPr indent="0" marL="0">
-                        <a:buNone/>
-                      </a:pPr>
-                      <a:r>
-                        <a:rPr lang="en-US" sz="1500" dirty="0">
-                          <a:solidFill>
-                            <a:srgbClr val="1B1F24"/>
-                          </a:solidFill>
-                          <a:latin typeface="Nyala" pitchFamily="34" charset="0"/>
-                          <a:ea typeface="Nyala" pitchFamily="34" charset="-122"/>
-                          <a:cs typeface="Nyala" pitchFamily="34" charset="-120"/>
-                        </a:rPr>
-                        <a:t>(new sentence)</a:t>
-                      </a:r>
-                      <a:endParaRPr lang="en-US" sz="1500" dirty="0">
-                        <a:latin typeface="Nyala" charset="0"/>
-                        <a:ea typeface="Nyala" charset="0"/>
-                        <a:cs typeface="Nyala" charset="0"/>
-                      </a:endParaRPr>
-                    </a:p>
-                  </a:txBody>
-                  <a:tcPr marL="91440" marR="91440" marT="45720" marB="45720" anchor="ctr">
-                    <a:lnL w="0" cap="flat" cmpd="sng" algn="ctr">
-                      <a:noFill/>
-                    </a:lnL>
-                    <a:lnR w="0" cap="flat" cmpd="sng" algn="ctr">
-                      <a:noFill/>
-                    </a:lnR>
-                    <a:lnT w="0" cap="flat" cmpd="sng" algn="ctr">
-                      <a:noFill/>
-                    </a:lnT>
-                    <a:lnB w="0" cap="flat" cmpd="sng" algn="ctr">
-                      <a:noFill/>
-                    </a:lnB>
-                    <a:solidFill>
-                      <a:srgbClr val="FFFFFF"/>
-                    </a:solidFill>
-                  </a:tcPr>
-                </a:tc>
-                <a:tc>
-                  <a:txBody>
-                    <a:bodyPr/>
-                    <a:lstStyle/>
-                    <a:p>
-                      <a:pPr indent="0" marL="0">
-                        <a:buNone/>
-                      </a:pPr>
-                      <a:r>
-                        <a:rPr lang="en-US" sz="1500" dirty="0">
-                          <a:solidFill>
-                            <a:srgbClr val="1B1F24"/>
-                          </a:solidFill>
-                          <a:latin typeface="Nyala" pitchFamily="34" charset="0"/>
-                          <a:ea typeface="Nyala" pitchFamily="34" charset="-122"/>
-                          <a:cs typeface="Nyala" pitchFamily="34" charset="-120"/>
-                        </a:rPr>
-                        <a:t>መጽሀፍ ቅዱስን ማጥናት ይኖርብናል።</a:t>
-                      </a:r>
-                      <a:endParaRPr lang="en-US" sz="1500" dirty="0">
-                        <a:latin typeface="Nyala" charset="0"/>
-                        <a:ea typeface="Nyala" charset="0"/>
-                        <a:cs typeface="Nyala" charset="0"/>
-                      </a:endParaRPr>
-                    </a:p>
-                  </a:txBody>
-                  <a:tcPr marL="91440" marR="91440" marT="45720" marB="45720" anchor="ctr">
-                    <a:lnL w="0" cap="flat" cmpd="sng" algn="ctr">
-                      <a:noFill/>
-                    </a:lnL>
-                    <a:lnR w="0" cap="flat" cmpd="sng" algn="ctr">
-                      <a:noFill/>
-                    </a:lnR>
-                    <a:lnT w="0" cap="flat" cmpd="sng" algn="ctr">
-                      <a:noFill/>
-                    </a:lnT>
-                    <a:lnB w="0" cap="flat" cmpd="sng" algn="ctr">
-                      <a:noFill/>
-                    </a:lnB>
-                    <a:solidFill>
-                      <a:srgbClr val="FFFFFF"/>
+                      <a:srgbClr val="F4F7F6"/>
                     </a:solidFill>
                   </a:tcPr>
                 </a:tc>
@@ -9855,6 +9662,184 @@
                       <a:noFill/>
                     </a:lnB>
                     <a:solidFill>
+                      <a:srgbClr val="F4F7F6"/>
+                    </a:solidFill>
+                  </a:tcPr>
+                </a:tc>
+                <a:tc>
+                  <a:txBody>
+                    <a:bodyPr/>
+                    <a:lstStyle/>
+                    <a:p>
+                      <a:pPr indent="0" marL="0">
+                        <a:buNone/>
+                      </a:pPr>
+                      <a:r>
+                        <a:rPr lang="en-US" sz="1500" dirty="0">
+                          <a:solidFill>
+                            <a:srgbClr val="1B1F24"/>
+                          </a:solidFill>
+                          <a:latin typeface="Nyala" pitchFamily="34" charset="0"/>
+                          <a:ea typeface="Nyala" pitchFamily="34" charset="-122"/>
+                          <a:cs typeface="Nyala" pitchFamily="34" charset="-120"/>
+                        </a:rPr>
+                        <a:t>በየእለቱ መጽሀፍ ቅዱስን ማንበብ ይኖርብናል።</a:t>
+                      </a:r>
+                      <a:endParaRPr lang="en-US" sz="1500" dirty="0">
+                        <a:latin typeface="Nyala" charset="0"/>
+                        <a:ea typeface="Nyala" charset="0"/>
+                        <a:cs typeface="Nyala" charset="0"/>
+                      </a:endParaRPr>
+                    </a:p>
+                  </a:txBody>
+                  <a:tcPr marL="91440" marR="91440" marT="45720" marB="45720" anchor="ctr">
+                    <a:lnL w="0" cap="flat" cmpd="sng" algn="ctr">
+                      <a:noFill/>
+                    </a:lnL>
+                    <a:lnR w="0" cap="flat" cmpd="sng" algn="ctr">
+                      <a:noFill/>
+                    </a:lnR>
+                    <a:lnT w="0" cap="flat" cmpd="sng" algn="ctr">
+                      <a:noFill/>
+                    </a:lnT>
+                    <a:lnB w="0" cap="flat" cmpd="sng" algn="ctr">
+                      <a:noFill/>
+                    </a:lnB>
+                    <a:solidFill>
+                      <a:srgbClr val="F4F7F6"/>
+                    </a:solidFill>
+                  </a:tcPr>
+                </a:tc>
+              </a:tr>
+              <a:tr h="731520">
+                <a:tc>
+                  <a:txBody>
+                    <a:bodyPr/>
+                    <a:lstStyle/>
+                    <a:p>
+                      <a:pPr indent="0" marL="0">
+                        <a:buNone/>
+                      </a:pPr>
+                      <a:r>
+                        <a:rPr lang="en-US" sz="1300" dirty="0">
+                          <a:solidFill>
+                            <a:srgbClr val="1B1F24"/>
+                          </a:solidFill>
+                          <a:latin typeface="Calibri" pitchFamily="34" charset="0"/>
+                          <a:ea typeface="Calibri" pitchFamily="34" charset="-122"/>
+                          <a:cs typeface="Calibri" pitchFamily="34" charset="-120"/>
+                        </a:rPr>
+                        <a:t>God created the heavens and the earth.</a:t>
+                      </a:r>
+                      <a:endParaRPr lang="en-US" sz="1300" dirty="0">
+                        <a:latin typeface="Calibri" charset="0"/>
+                        <a:ea typeface="Calibri" charset="0"/>
+                        <a:cs typeface="Calibri" charset="0"/>
+                      </a:endParaRPr>
+                    </a:p>
+                  </a:txBody>
+                  <a:tcPr marL="91440" marR="91440" marT="45720" marB="45720" anchor="ctr">
+                    <a:lnL w="0" cap="flat" cmpd="sng" algn="ctr">
+                      <a:noFill/>
+                    </a:lnL>
+                    <a:lnR w="0" cap="flat" cmpd="sng" algn="ctr">
+                      <a:noFill/>
+                    </a:lnR>
+                    <a:lnT w="0" cap="flat" cmpd="sng" algn="ctr">
+                      <a:noFill/>
+                    </a:lnT>
+                    <a:lnB w="0" cap="flat" cmpd="sng" algn="ctr">
+                      <a:noFill/>
+                    </a:lnB>
+                    <a:solidFill>
+                      <a:srgbClr val="FFFFFF"/>
+                    </a:solidFill>
+                  </a:tcPr>
+                </a:tc>
+                <a:tc>
+                  <a:txBody>
+                    <a:bodyPr/>
+                    <a:lstStyle/>
+                    <a:p>
+                      <a:pPr indent="0" marL="0">
+                        <a:buNone/>
+                      </a:pPr>
+                      <a:r>
+                        <a:rPr lang="en-US" sz="1500" dirty="0">
+                          <a:solidFill>
+                            <a:srgbClr val="1B1F24"/>
+                          </a:solidFill>
+                          <a:latin typeface="Nyala" pitchFamily="34" charset="0"/>
+                          <a:ea typeface="Nyala" pitchFamily="34" charset="-122"/>
+                          <a:cs typeface="Nyala" pitchFamily="34" charset="-120"/>
+                        </a:rPr>
+                        <a:t>አምላክ ሰማያትንና ምድርን ፈጠረ።</a:t>
+                      </a:r>
+                      <a:endParaRPr lang="en-US" sz="1500" dirty="0">
+                        <a:latin typeface="Nyala" charset="0"/>
+                        <a:ea typeface="Nyala" charset="0"/>
+                        <a:cs typeface="Nyala" charset="0"/>
+                      </a:endParaRPr>
+                    </a:p>
+                  </a:txBody>
+                  <a:tcPr marL="91440" marR="91440" marT="45720" marB="45720" anchor="ctr">
+                    <a:lnL w="0" cap="flat" cmpd="sng" algn="ctr">
+                      <a:noFill/>
+                    </a:lnL>
+                    <a:lnR w="0" cap="flat" cmpd="sng" algn="ctr">
+                      <a:noFill/>
+                    </a:lnR>
+                    <a:lnT w="0" cap="flat" cmpd="sng" algn="ctr">
+                      <a:noFill/>
+                    </a:lnT>
+                    <a:lnB w="0" cap="flat" cmpd="sng" algn="ctr">
+                      <a:noFill/>
+                    </a:lnB>
+                    <a:solidFill>
+                      <a:srgbClr val="FFFFFF"/>
+                    </a:solidFill>
+                  </a:tcPr>
+                </a:tc>
+                <a:tc>
+                  <a:txBody>
+                    <a:bodyPr/>
+                    <a:lstStyle/>
+                    <a:p>
+                      <a:pPr indent="0" marL="0">
+                        <a:buNone/>
+                      </a:pPr>
+                      <a:r>
+                        <a:rPr lang="en-US" sz="1500" dirty="0">
+                          <a:solidFill>
+                            <a:srgbClr val="1B1F24"/>
+                          </a:solidFill>
+                          <a:latin typeface="Nyala" pitchFamily="34" charset="0"/>
+                          <a:ea typeface="Nyala" pitchFamily="34" charset="-122"/>
+                          <a:cs typeface="Nyala" pitchFamily="34" charset="-120"/>
+                        </a:rPr>
+                        <a:t>ሰማያትንና ምድርን ፈጠረ።</a:t>
+                      </a:r>
+                      <a:endParaRPr lang="en-US" sz="1500" dirty="0">
+                        <a:latin typeface="Nyala" charset="0"/>
+                        <a:ea typeface="Nyala" charset="0"/>
+                        <a:cs typeface="Nyala" charset="0"/>
+                      </a:endParaRPr>
+                    </a:p>
+                  </a:txBody>
+                  <a:tcPr marL="91440" marR="91440" marT="45720" marB="45720" anchor="ctr">
+                    <a:lnL w="0" cap="flat" cmpd="sng" algn="ctr">
+                      <a:noFill/>
+                    </a:lnL>
+                    <a:lnR w="0" cap="flat" cmpd="sng" algn="ctr">
+                      <a:noFill/>
+                    </a:lnR>
+                    <a:lnT w="0" cap="flat" cmpd="sng" algn="ctr">
+                      <a:noFill/>
+                    </a:lnT>
+                    <a:lnB w="0" cap="flat" cmpd="sng" algn="ctr">
+                      <a:noFill/>
+                    </a:lnB>
+                    <a:solidFill>
                       <a:srgbClr val="FFFFFF"/>
                     </a:solidFill>
                   </a:tcPr>
@@ -9878,7 +9863,7 @@
                           <a:ea typeface="Calibri" pitchFamily="34" charset="-122"/>
                           <a:cs typeface="Calibri" pitchFamily="34" charset="-120"/>
                         </a:rPr>
-                        <a:t>I am going to the university.</a:t>
+                        <a:t>if it did , could we protect ourselves ?</a:t>
                       </a:r>
                       <a:endParaRPr lang="en-US" sz="1300" dirty="0">
                         <a:latin typeface="Calibri" charset="0"/>
@@ -9922,7 +9907,7 @@
                           <a:ea typeface="Nyala" pitchFamily="34" charset="-122"/>
                           <a:cs typeface="Nyala" pitchFamily="34" charset="-120"/>
                         </a:rPr>
-                        <a:t>ወደ ዩኒቨርሲቲ እሄዳለሁ።</a:t>
+                        <a:t>እንዲህ ማድረግ የምንችለው እንዴት ነው?</a:t>
                       </a:r>
                       <a:endParaRPr lang="en-US" sz="1500" dirty="0">
                         <a:latin typeface="Nyala" charset="0"/>
@@ -9966,51 +9951,7 @@
                           <a:ea typeface="Nyala" pitchFamily="34" charset="-122"/>
                           <a:cs typeface="Nyala" pitchFamily="34" charset="-120"/>
                         </a:rPr>
-                        <a:t>እኔ ግን እኔ ነኝ።</a:t>
-                      </a:r>
-                      <a:endParaRPr lang="en-US" sz="1500" dirty="0">
-                        <a:latin typeface="Nyala" charset="0"/>
-                        <a:ea typeface="Nyala" charset="0"/>
-                        <a:cs typeface="Nyala" charset="0"/>
-                      </a:endParaRPr>
-                    </a:p>
-                  </a:txBody>
-                  <a:tcPr marL="91440" marR="91440" marT="45720" marB="45720" anchor="ctr">
-                    <a:lnL w="0" cap="flat" cmpd="sng" algn="ctr">
-                      <a:noFill/>
-                    </a:lnL>
-                    <a:lnR w="0" cap="flat" cmpd="sng" algn="ctr">
-                      <a:noFill/>
-                    </a:lnR>
-                    <a:lnT w="0" cap="flat" cmpd="sng" algn="ctr">
-                      <a:noFill/>
-                    </a:lnT>
-                    <a:lnB w="0" cap="flat" cmpd="sng" algn="ctr">
-                      <a:noFill/>
-                    </a:lnB>
-                    <a:solidFill>
-                      <a:srgbClr val="F4F7F6"/>
-                    </a:solidFill>
-                  </a:tcPr>
-                </a:tc>
-                <a:tc>
-                  <a:txBody>
-                    <a:bodyPr/>
-                    <a:lstStyle/>
-                    <a:p>
-                      <a:pPr indent="0" marL="0">
-                        <a:buNone/>
-                      </a:pPr>
-                      <a:r>
-                        <a:rPr lang="en-US" sz="1500" dirty="0">
-                          <a:solidFill>
-                            <a:srgbClr val="1B1F24"/>
-                          </a:solidFill>
-                          <a:latin typeface="Nyala" pitchFamily="34" charset="0"/>
-                          <a:ea typeface="Nyala" pitchFamily="34" charset="-122"/>
-                          <a:cs typeface="Nyala" pitchFamily="34" charset="-120"/>
-                        </a:rPr>
-                        <a:t>እኔ ደግሞ በስሜት ቆየሁ።</a:t>
+                        <a:t>ታዲያ ራሳችንን መጠበቅ እንችላለን?</a:t>
                       </a:r>
                       <a:endParaRPr lang="en-US" sz="1500" dirty="0">
                         <a:latin typeface="Nyala" charset="0"/>
@@ -10075,7 +10016,7 @@
                 <a:ea typeface="Calibri" pitchFamily="34" charset="-122"/>
                 <a:cs typeface="Calibri" pitchFamily="34" charset="-120"/>
               </a:rPr>
-              <a:t>The last row shows the domain limit: everyday words such as “university” are rare in this religious corpus.</a:t>
+              <a:t>With the added habtew data, everyday sentences like “university” now work; long rare sentences remain hard.</a:t>
             </a:r>
             <a:endParaRPr lang="en-US" sz="1300" dirty="0"/>
           </a:p>
@@ -10516,7 +10457,7 @@
                           <a:ea typeface="Calibri" pitchFamily="34" charset="-122"/>
                           <a:cs typeface="Calibri" pitchFamily="34" charset="-120"/>
                         </a:rPr>
-                        <a:t>26.64%</a:t>
+                        <a:t>40.22%</a:t>
                       </a:r>
                       <a:endParaRPr lang="en-US" sz="1300" dirty="0">
                         <a:latin typeface="Calibri" charset="0"/>
@@ -10581,7 +10522,7 @@
                           <a:ea typeface="Calibri" pitchFamily="34" charset="-122"/>
                           <a:cs typeface="Calibri" pitchFamily="34" charset="-120"/>
                         </a:rPr>
-                        <a:t>17.16%</a:t>
+                        <a:t>26.12%</a:t>
                       </a:r>
                       <a:endParaRPr lang="en-US" sz="1300" dirty="0">
                         <a:latin typeface="Calibri" charset="0"/>
@@ -10713,7 +10654,7 @@
                           <a:ea typeface="Calibri" pitchFamily="34" charset="-122"/>
                           <a:cs typeface="Calibri" pitchFamily="34" charset="-120"/>
                         </a:rPr>
-                        <a:t>10.06%</a:t>
+                        <a:t>5.86%</a:t>
                       </a:r>
                       <a:endParaRPr lang="en-US" sz="1300" dirty="0">
                         <a:latin typeface="Calibri" charset="0"/>
@@ -10778,7 +10719,7 @@
                           <a:ea typeface="Calibri" pitchFamily="34" charset="-122"/>
                           <a:cs typeface="Calibri" pitchFamily="34" charset="-120"/>
                         </a:rPr>
-                        <a:t>13.72%</a:t>
+                        <a:t>6.38%</a:t>
                       </a:r>
                       <a:endParaRPr lang="en-US" sz="1300" dirty="0">
                         <a:latin typeface="Calibri" charset="0"/>
@@ -10910,7 +10851,7 @@
                           <a:ea typeface="Calibri" pitchFamily="34" charset="-122"/>
                           <a:cs typeface="Calibri" pitchFamily="34" charset="-120"/>
                         </a:rPr>
-                        <a:t>18.94%</a:t>
+                        <a:t>5.88%</a:t>
                       </a:r>
                       <a:endParaRPr lang="en-US" sz="1300" dirty="0">
                         <a:latin typeface="Calibri" charset="0"/>
@@ -10975,7 +10916,7 @@
                           <a:ea typeface="Calibri" pitchFamily="34" charset="-122"/>
                           <a:cs typeface="Calibri" pitchFamily="34" charset="-120"/>
                         </a:rPr>
-                        <a:t>24.12%</a:t>
+                        <a:t>8.34%</a:t>
                       </a:r>
                       <a:endParaRPr lang="en-US" sz="1300" dirty="0">
                         <a:latin typeface="Calibri" charset="0"/>
@@ -11107,7 +11048,7 @@
                           <a:ea typeface="Calibri" pitchFamily="34" charset="-122"/>
                           <a:cs typeface="Calibri" pitchFamily="34" charset="-120"/>
                         </a:rPr>
-                        <a:t>0.94</a:t>
+                        <a:t>0.953</a:t>
                       </a:r>
                       <a:endParaRPr lang="en-US" sz="1300" dirty="0">
                         <a:latin typeface="Calibri" charset="0"/>
@@ -11172,7 +11113,7 @@
                           <a:ea typeface="Calibri" pitchFamily="34" charset="-122"/>
                           <a:cs typeface="Calibri" pitchFamily="34" charset="-120"/>
                         </a:rPr>
-                        <a:t>0.942</a:t>
+                        <a:t>0.95</a:t>
                       </a:r>
                       <a:endParaRPr lang="en-US" sz="1300" dirty="0">
                         <a:latin typeface="Calibri" charset="0"/>
@@ -11304,7 +11245,7 @@
                           <a:ea typeface="Calibri" pitchFamily="34" charset="-122"/>
                           <a:cs typeface="Calibri" pitchFamily="34" charset="-120"/>
                         </a:rPr>
-                        <a:t>3.71%</a:t>
+                        <a:t>3.82%</a:t>
                       </a:r>
                       <a:endParaRPr lang="en-US" sz="1300" dirty="0">
                         <a:latin typeface="Calibri" charset="0"/>
@@ -11369,7 +11310,7 @@
                           <a:ea typeface="Calibri" pitchFamily="34" charset="-122"/>
                           <a:cs typeface="Calibri" pitchFamily="34" charset="-120"/>
                         </a:rPr>
-                        <a:t>5.66%</a:t>
+                        <a:t>5.62%</a:t>
                       </a:r>
                       <a:endParaRPr lang="en-US" sz="1300" dirty="0">
                         <a:latin typeface="Calibri" charset="0"/>
@@ -11501,7 +11442,7 @@
                           <a:ea typeface="Calibri" pitchFamily="34" charset="-122"/>
                           <a:cs typeface="Calibri" pitchFamily="34" charset="-120"/>
                         </a:rPr>
-                        <a:t>85.08%</a:t>
+                        <a:t>81.85%</a:t>
                       </a:r>
                       <a:endParaRPr lang="en-US" sz="1300" dirty="0">
                         <a:latin typeface="Calibri" charset="0"/>
@@ -11566,7 +11507,7 @@
                           <a:ea typeface="Calibri" pitchFamily="34" charset="-122"/>
                           <a:cs typeface="Calibri" pitchFamily="34" charset="-120"/>
                         </a:rPr>
-                        <a:t>89.42%</a:t>
+                        <a:t>88.23%</a:t>
                       </a:r>
                       <a:endParaRPr lang="en-US" sz="1300" dirty="0">
                         <a:latin typeface="Calibri" charset="0"/>
@@ -11698,7 +11639,7 @@
                           <a:ea typeface="Calibri" pitchFamily="34" charset="-122"/>
                           <a:cs typeface="Calibri" pitchFamily="34" charset="-120"/>
                         </a:rPr>
-                        <a:t>38.28%</a:t>
+                        <a:t>70.77%</a:t>
                       </a:r>
                       <a:endParaRPr lang="en-US" sz="1300" dirty="0">
                         <a:latin typeface="Calibri" charset="0"/>
@@ -11763,7 +11704,7 @@
                           <a:ea typeface="Calibri" pitchFamily="34" charset="-122"/>
                           <a:cs typeface="Calibri" pitchFamily="34" charset="-120"/>
                         </a:rPr>
-                        <a:t>93.55%</a:t>
+                        <a:t>96.58%</a:t>
                       </a:r>
                       <a:endParaRPr lang="en-US" sz="1300" dirty="0">
                         <a:latin typeface="Calibri" charset="0"/>
@@ -11895,7 +11836,7 @@
                           <a:ea typeface="Calibri" pitchFamily="34" charset="-122"/>
                           <a:cs typeface="Calibri" pitchFamily="34" charset="-120"/>
                         </a:rPr>
-                        <a:t>0.73</a:t>
+                        <a:t>1.87</a:t>
                       </a:r>
                       <a:endParaRPr lang="en-US" sz="1300" dirty="0">
                         <a:latin typeface="Calibri" charset="0"/>
@@ -11960,7 +11901,7 @@
                           <a:ea typeface="Calibri" pitchFamily="34" charset="-122"/>
                           <a:cs typeface="Calibri" pitchFamily="34" charset="-120"/>
                         </a:rPr>
-                        <a:t>3.22</a:t>
+                        <a:t>4.19</a:t>
                       </a:r>
                       <a:endParaRPr lang="en-US" sz="1300" dirty="0">
                         <a:latin typeface="Calibri" charset="0"/>
@@ -12261,7 +12202,7 @@
                 <a:ea typeface="Calibri" pitchFamily="34" charset="-122"/>
                 <a:cs typeface="Calibri" pitchFamily="34" charset="-120"/>
               </a:rPr>
-              <a:t>“We must read the Bible every day” → the order is reversed: Bible, every day, read, must</a:t>
+              <a:t>“We must read the Bible every day” → Amharic order: every day, Bible, read, must</a:t>
             </a:r>
             <a:endParaRPr lang="en-US" sz="1400" dirty="0"/>
           </a:p>
@@ -12303,7 +12244,7 @@
                 <a:ea typeface="Calibri" pitchFamily="34" charset="-122"/>
                 <a:cs typeface="Calibri" pitchFamily="34" charset="-120"/>
               </a:rPr>
-              <a:t>Failure case “university”: attention is diffuse and a frequent phrase is produced instead</a:t>
+              <a:t>“I am going to the university” → ወደ ዩኒቨርሲቲው ሄድኩ: ዩኒቨርሲቲ attends to “university”, the suffix -ኩ to “I”</a:t>
             </a:r>
             <a:endParaRPr lang="en-US" sz="1400" dirty="0"/>
           </a:p>

</xml_diff>

<commit_message>
Add group members to README, report, slides and demo page
Co-Authored-By: Claude Opus 5.5 <noreply@anthropic.com>
Claude-Session: https://claude.ai/code/session_01PDKn43w3hK6bUWpz4Q72jr
</commit_message>
<xml_diff>
--- a/report/presentation.pptx
+++ b/report/presentation.pptx
@@ -2841,7 +2841,7 @@
         </p:nvSpPr>
         <p:spPr>
           <a:xfrm>
-            <a:off x="731520" y="5120640"/>
+            <a:off x="731520" y="4069080"/>
             <a:ext cx="10515600" cy="365760"/>
           </a:xfrm>
           <a:prstGeom prst="rect">
@@ -2866,7 +2866,7 @@
                 <a:ea typeface="Calibri" pitchFamily="34" charset="-122"/>
                 <a:cs typeface="Calibri" pitchFamily="34" charset="-120"/>
               </a:rPr>
-              <a:t>Deep Learning Course Project  ·  Instructor: Fantahun Bogale Gereme  ·  Group: [member names]</a:t>
+              <a:t>Deep Learning Course Project  ·  Instructor: Fantahun Bogale Gereme</a:t>
             </a:r>
             <a:endParaRPr lang="en-US" sz="1600" dirty="0"/>
           </a:p>
@@ -2880,7 +2880,219 @@
         </p:nvSpPr>
         <p:spPr>
           <a:xfrm>
-            <a:off x="731520" y="5532120"/>
+            <a:off x="731520" y="4526280"/>
+            <a:ext cx="4389120" cy="365760"/>
+          </a:xfrm>
+          <a:prstGeom prst="rect">
+            <a:avLst/>
+          </a:prstGeom>
+          <a:noFill/>
+          <a:ln/>
+        </p:spPr>
+        <p:txBody>
+          <a:bodyPr wrap="square" lIns="0" tIns="0" rIns="0" bIns="0" rtlCol="0" anchor="ctr"/>
+          <a:lstStyle/>
+          <a:p>
+            <a:pPr indent="0" marL="0">
+              <a:buNone/>
+            </a:pPr>
+            <a:r>
+              <a:rPr lang="en-US" sz="1500" b="1" dirty="0">
+                <a:solidFill>
+                  <a:srgbClr val="FFFFFF"/>
+                </a:solidFill>
+                <a:latin typeface="Calibri" pitchFamily="34" charset="0"/>
+                <a:ea typeface="Calibri" pitchFamily="34" charset="-122"/>
+                <a:cs typeface="Calibri" pitchFamily="34" charset="-120"/>
+              </a:rPr>
+              <a:t>Bethel Negusu</a:t>
+            </a:r>
+            <a:pPr indent="0" marL="0">
+              <a:buNone/>
+            </a:pPr>
+            <a:r>
+              <a:rPr lang="en-US" sz="1500" dirty="0">
+                <a:solidFill>
+                  <a:srgbClr val="DCEEE7"/>
+                </a:solidFill>
+                <a:latin typeface="Calibri" pitchFamily="34" charset="0"/>
+                <a:ea typeface="Calibri" pitchFamily="34" charset="-122"/>
+                <a:cs typeface="Calibri" pitchFamily="34" charset="-120"/>
+              </a:rPr>
+              <a:t>   GSR/8221/18</a:t>
+            </a:r>
+            <a:endParaRPr lang="en-US" sz="1500" dirty="0"/>
+          </a:p>
+        </p:txBody>
+      </p:sp>
+      <p:sp>
+        <p:nvSpPr>
+          <p:cNvPr id="7" name="Text 5"/>
+          <p:cNvSpPr txBox="1"/>
+          <p:nvPr/>
+        </p:nvSpPr>
+        <p:spPr>
+          <a:xfrm>
+            <a:off x="5303520" y="4526280"/>
+            <a:ext cx="4389120" cy="365760"/>
+          </a:xfrm>
+          <a:prstGeom prst="rect">
+            <a:avLst/>
+          </a:prstGeom>
+          <a:noFill/>
+          <a:ln/>
+        </p:spPr>
+        <p:txBody>
+          <a:bodyPr wrap="square" lIns="0" tIns="0" rIns="0" bIns="0" rtlCol="0" anchor="ctr"/>
+          <a:lstStyle/>
+          <a:p>
+            <a:pPr indent="0" marL="0">
+              <a:buNone/>
+            </a:pPr>
+            <a:r>
+              <a:rPr lang="en-US" sz="1500" b="1" dirty="0">
+                <a:solidFill>
+                  <a:srgbClr val="FFFFFF"/>
+                </a:solidFill>
+                <a:latin typeface="Calibri" pitchFamily="34" charset="0"/>
+                <a:ea typeface="Calibri" pitchFamily="34" charset="-122"/>
+                <a:cs typeface="Calibri" pitchFamily="34" charset="-120"/>
+              </a:rPr>
+              <a:t>Esrom Adugna</a:t>
+            </a:r>
+            <a:pPr indent="0" marL="0">
+              <a:buNone/>
+            </a:pPr>
+            <a:r>
+              <a:rPr lang="en-US" sz="1500" dirty="0">
+                <a:solidFill>
+                  <a:srgbClr val="DCEEE7"/>
+                </a:solidFill>
+                <a:latin typeface="Calibri" pitchFamily="34" charset="0"/>
+                <a:ea typeface="Calibri" pitchFamily="34" charset="-122"/>
+                <a:cs typeface="Calibri" pitchFamily="34" charset="-120"/>
+              </a:rPr>
+              <a:t>   GSR/4064/18</a:t>
+            </a:r>
+            <a:endParaRPr lang="en-US" sz="1500" dirty="0"/>
+          </a:p>
+        </p:txBody>
+      </p:sp>
+      <p:sp>
+        <p:nvSpPr>
+          <p:cNvPr id="8" name="Text 6"/>
+          <p:cNvSpPr txBox="1"/>
+          <p:nvPr/>
+        </p:nvSpPr>
+        <p:spPr>
+          <a:xfrm>
+            <a:off x="731520" y="4937760"/>
+            <a:ext cx="4389120" cy="365760"/>
+          </a:xfrm>
+          <a:prstGeom prst="rect">
+            <a:avLst/>
+          </a:prstGeom>
+          <a:noFill/>
+          <a:ln/>
+        </p:spPr>
+        <p:txBody>
+          <a:bodyPr wrap="square" lIns="0" tIns="0" rIns="0" bIns="0" rtlCol="0" anchor="ctr"/>
+          <a:lstStyle/>
+          <a:p>
+            <a:pPr indent="0" marL="0">
+              <a:buNone/>
+            </a:pPr>
+            <a:r>
+              <a:rPr lang="en-US" sz="1500" b="1" dirty="0">
+                <a:solidFill>
+                  <a:srgbClr val="FFFFFF"/>
+                </a:solidFill>
+                <a:latin typeface="Calibri" pitchFamily="34" charset="0"/>
+                <a:ea typeface="Calibri" pitchFamily="34" charset="-122"/>
+                <a:cs typeface="Calibri" pitchFamily="34" charset="-120"/>
+              </a:rPr>
+              <a:t>Selamawit Siferh</a:t>
+            </a:r>
+            <a:pPr indent="0" marL="0">
+              <a:buNone/>
+            </a:pPr>
+            <a:r>
+              <a:rPr lang="en-US" sz="1500" dirty="0">
+                <a:solidFill>
+                  <a:srgbClr val="DCEEE7"/>
+                </a:solidFill>
+                <a:latin typeface="Calibri" pitchFamily="34" charset="0"/>
+                <a:ea typeface="Calibri" pitchFamily="34" charset="-122"/>
+                <a:cs typeface="Calibri" pitchFamily="34" charset="-120"/>
+              </a:rPr>
+              <a:t>   GSR/6879/18</a:t>
+            </a:r>
+            <a:endParaRPr lang="en-US" sz="1500" dirty="0"/>
+          </a:p>
+        </p:txBody>
+      </p:sp>
+      <p:sp>
+        <p:nvSpPr>
+          <p:cNvPr id="9" name="Text 7"/>
+          <p:cNvSpPr txBox="1"/>
+          <p:nvPr/>
+        </p:nvSpPr>
+        <p:spPr>
+          <a:xfrm>
+            <a:off x="5303520" y="4937760"/>
+            <a:ext cx="4389120" cy="365760"/>
+          </a:xfrm>
+          <a:prstGeom prst="rect">
+            <a:avLst/>
+          </a:prstGeom>
+          <a:noFill/>
+          <a:ln/>
+        </p:spPr>
+        <p:txBody>
+          <a:bodyPr wrap="square" lIns="0" tIns="0" rIns="0" bIns="0" rtlCol="0" anchor="ctr"/>
+          <a:lstStyle/>
+          <a:p>
+            <a:pPr indent="0" marL="0">
+              <a:buNone/>
+            </a:pPr>
+            <a:r>
+              <a:rPr lang="en-US" sz="1500" b="1" dirty="0">
+                <a:solidFill>
+                  <a:srgbClr val="FFFFFF"/>
+                </a:solidFill>
+                <a:latin typeface="Calibri" pitchFamily="34" charset="0"/>
+                <a:ea typeface="Calibri" pitchFamily="34" charset="-122"/>
+                <a:cs typeface="Calibri" pitchFamily="34" charset="-120"/>
+              </a:rPr>
+              <a:t>Aklilu Solomon</a:t>
+            </a:r>
+            <a:pPr indent="0" marL="0">
+              <a:buNone/>
+            </a:pPr>
+            <a:r>
+              <a:rPr lang="en-US" sz="1500" dirty="0">
+                <a:solidFill>
+                  <a:srgbClr val="DCEEE7"/>
+                </a:solidFill>
+                <a:latin typeface="Calibri" pitchFamily="34" charset="0"/>
+                <a:ea typeface="Calibri" pitchFamily="34" charset="-122"/>
+                <a:cs typeface="Calibri" pitchFamily="34" charset="-120"/>
+              </a:rPr>
+              <a:t>   GSE/0756/18</a:t>
+            </a:r>
+            <a:endParaRPr lang="en-US" sz="1500" dirty="0"/>
+          </a:p>
+        </p:txBody>
+      </p:sp>
+      <p:sp>
+        <p:nvSpPr>
+          <p:cNvPr id="10" name="Text 8"/>
+          <p:cNvSpPr txBox="1"/>
+          <p:nvPr/>
+        </p:nvSpPr>
+        <p:spPr>
+          <a:xfrm>
+            <a:off x="731520" y="5760720"/>
             <a:ext cx="10515600" cy="365760"/>
           </a:xfrm>
           <a:prstGeom prst="rect">

</xml_diff>